<commit_message>
RML2016.10a noise is not reused: yesterday's 'deterministic channel' was GNU Radio 3.10, not the dataset
rml2016_noise_reuse.json (Colab, on the pickle): 0 of 11,000 frames at -20
dB and at -16 dB share a noise segment with another frame; one pair at -18
dB (BPSK / WBFM, 118 samples). The same test finds partners for 17% of
frames when the noise is known to be shared.

The reason is in GNU Radio 3.7.10's source: the noise and both offset walks
pick from seeded 8,192-sample pools with the unseeded, process-wide
lrand48(), so they differ run to run. 3.10 replaced that with a seeded
xoroshiro, which is why the rebuilt channel was bit-identical across runs.
Only the fading has its own seeded generator in 3.7 and repeats.

NOISE_2016.md, CLAUDE.md, slide 6 and its notes corrected; the channel
audit tool now says its result is 3.10's behaviour.

Co-Authored-By: Claude Opus 5.5 <noreply@anthropic.com>
Claude-Session: https://claude.ai/code/session_01UiTC1BeuJK5BZLbarMcqjw
</commit_message>
<xml_diff>
--- a/deck/moshe_2016.pptx
+++ b/deck/moshe_2016.pptx
@@ -2025,7 +2025,7 @@
           <a:p>
             <a:r>
               <a:rPr lang="en-US" dirty="0"/>
-              <a:t>Who made the noise. DeepSig, in GNU Radio, entirely synthetic. The paper names the channel block and gives no parameters at all, so these come from the generator code they published. The important point is on the right: noise is only one of five impairments. Carrier offset, clock offset, Rician fading and three-path multipath are there at every SNR, including plus 18. And the SNR label sets exactly one number: the noise amplitude, 10 to the minus label over 10. One more property I found in GNU Radio's source: every part of this channel is seeded with the same fixed number, and the generator builds a fresh channel for each run. So every run, for every class and every SNR, sees exactly the same channel and the same noise sequence, only scaled. The carrier offset can go up to 500 Hz in principle, but the random walk only reaches about 4 Hz in a run, so within a frame it rotates by less than a degree.</a:t>
+              <a:t>Who made the noise. DeepSig, in GNU Radio, entirely synthetic. The paper names the channel block and gives no parameters at all, so these come from the generator code they published. The important point is on the right: noise is only one of five impairments. Carrier offset, clock offset, Rician fading and three-path multipath are there at every SNR, including plus 18. And the SNR label sets exactly one number: the noise amplitude, 10 to the minus label over 10. Two more properties. The carrier offset can go up to 500 Hz in principle, but the random walk only reaches a few hertz in a run, so within a frame it rotates by about a degree. And the generator seeds the channel with a fixed number; in today's GNU Radio that would make every run reuse the same noise, so I checked the file: among 11,000 frames at minus 20 dB, no two share a noise segment. The 2016 GNU Radio picked its noise with an unseeded generator, so the noise is fresh.</a:t>
             </a:r>
             <a:endParaRPr lang="en-US" dirty="0"/>
           </a:p>
@@ -13387,7 +13387,7 @@
                           <a:ea typeface="Calibri" pitchFamily="34" charset="-122"/>
                           <a:cs typeface="Calibri" pitchFamily="34" charset="-120"/>
                         </a:rPr>
-                        <a:t>reaches ~4 Hz in a run: under 1° of rotation per frame</a:t>
+                        <a:t>reaches only a few Hz in a run: about 1° of rotation per frame</a:t>
                       </a:r>
                       <a:endParaRPr lang="en-US" sz="1200" dirty="0">
                         <a:latin typeface="Calibri" charset="0"/>
@@ -14194,7 +14194,7 @@
                 <a:ea typeface="Calibri" pitchFamily="34" charset="-122"/>
                 <a:cs typeface="Calibri" pitchFamily="34" charset="-120"/>
               </a:rPr>
-              <a:t>Carrier offset, clock offset, fading and multipath are present at every SNR, including +18 dB. Errors at high SNR cannot be blamed on noise. And every part is seeded with the same fixed number: every run of the generator sees the identical channel and noise sequence.</a:t>
+              <a:t>Carrier offset, clock offset, fading and multipath are present at every SNR, including +18 dB. Errors at high SNR cannot be blamed on noise. The noise is fresh in every run: checked in the file, no two of 11,000 frames at −20 dB share a noise segment.</a:t>
             </a:r>
             <a:endParaRPr lang="en-US" sz="1250" dirty="0"/>
           </a:p>

</xml_diff>